<commit_message>
md -> beamer latex -> pptx pipeline
</commit_message>
<xml_diff>
--- a/final_paper/output/fdr_presentation.pptx
+++ b/final_paper/output/fdr_presentation.pptx
@@ -535,22 +535,7 @@
           <a:lstStyle/>
           <a:p>
             <a:r>
-              <a:t>We're TrayGuard. We spent two quarters looking at why surgical trays</a:t>
-            </a:r>
-          </a:p>
-          <a:p>
-            <a:r>
-              <a:t>    arrive wrong or incomplete, and what a team like ours can actually do</a:t>
-            </a:r>
-          </a:p>
-          <a:p>
-            <a:r>
-              <a:t>    about it. The answer turned out to be more interesting --- and more</a:t>
-            </a:r>
-          </a:p>
-          <a:p>
-            <a:r>
-              <a:t>    frustrating --- than a camera-based fix.</a:t>
+              <a:t>We're TrayGuard. We spent two quarters looking at why surgical trays arrive wrong or incomplete, and what a team like ours can actually do about it. The answer turned out to be more interesting — and more frustrating — than a camera-based fix.</a:t>
             </a:r>
           </a:p>
         </p:txBody>
@@ -620,22 +605,7 @@
           <a:lstStyle/>
           <a:p>
             <a:r>
-              <a:t>Left: separated layout -- what you'd train on. Right: overlay -- what</a:t>
-            </a:r>
-          </a:p>
-          <a:p>
-            <a:r>
-              <a:t>    a real tray looks like. When we trained separated and tested on overlay,</a:t>
-            </a:r>
-          </a:p>
-          <a:p>
-            <a:r>
-              <a:t>    mAP50-95 dropped from 0.995 to 0.389. You'd need to ask the technician to</a:t>
-            </a:r>
-          </a:p>
-          <a:p>
-            <a:r>
-              <a:t>    rearrange before scanning, which defeats the purpose.</a:t>
+              <a:t>This is the most telling experiment. Left: separated layout — what you'd train on. Right: overlay — what a real tray looks like. Instruments in a tray touch and overlap. When we trained separated and tested on overlay, mAP50-95 dropped from 0.995 to 0.389. That means every time instruments overlap — which is most of the time in a real tray — the detector can't reliably tell what's there. You'd need to ask the technician to stop and rearrange before scanning, which defeats the purpose of an automated check.</a:t>
             </a:r>
           </a:p>
         </p:txBody>
@@ -705,27 +675,13 @@
           <a:lstStyle/>
           <a:p>
             <a:r>
-              <a:t>This is diagnostic. Per-class AP ranges from 0.000 to 0.862 depending</a:t>
-            </a:r>
-          </a:p>
-          <a:p>
-            <a:r>
-              <a:t>    on the split. Different classes survive in different splits because the</a:t>
-            </a:r>
-          </a:p>
-          <a:p>
-            <a:r>
-              <a:t>    model memorizes positions, not shapes. The only class that transfers is</a:t>
-            </a:r>
-          </a:p>
-          <a:p>
-            <a:r>
-              <a:t>    scalpel -- the most visually distinct. This isn't fixable with more data</a:t>
-            </a:r>
-          </a:p>
-          <a:p>
-            <a:r>
-              <a:t>    alone; you'd need randomized positions.</a:t>
+              <a:t>This is the diagnostic result. We tested six real instrument classes — four scissors, a forcep, a scalpel. Per-class AP ranges from 0.000 to 0.862 depending on which split you look at. Different classes survive in different splits. The only class that transfers reliably is the scalpel — the most visually distinct instrument with a single blade versus multi-loop scissors.</a:t>
+            </a:r>
+          </a:p>
+          <a:p/>
+          <a:p>
+            <a:r>
+              <a:t>The pattern is caused by position-cue confounding. Each image has exactly one of each class at fixed positions per session. The model memorizes which class appears at which image location. When the position changes — which happens every time you process a different tray — the model fails. This isn't a problem you can fix with more data alone. You need randomized positions, which means a completely different data collection protocol.</a:t>
             </a:r>
           </a:p>
         </p:txBody>
@@ -795,27 +751,7 @@
           <a:lstStyle/>
           <a:p>
             <a:r>
-              <a:t>CV works in matched controlled conditions and degrades under every SPD</a:t>
-            </a:r>
-          </a:p>
-          <a:p>
-            <a:r>
-              <a:t>    variation. A deployment-grade system needs site-specific data for every</a:t>
-            </a:r>
-          </a:p>
-          <a:p>
-            <a:r>
-              <a:t>    hospital, cross-manufacturer validation, open-set rejection, human review,</a:t>
-            </a:r>
-          </a:p>
-          <a:p>
-            <a:r>
-              <a:t>    and regulatory clearance. We cannot responsibly build that in a quarter.</a:t>
-            </a:r>
-          </a:p>
-          <a:p>
-            <a:r>
-              <a:t>    The pivot was driven by this evidence.</a:t>
+              <a:t>The cumulative evidence is clear: CV detection works in matched, controlled conditions and degrades under every variation that SPD workflows present. A deployment-grade system would need site-specific data for every hospital, cross-manufacturer validation because Kienle showed big drops between brands, open-set rejection for unknown objects, human-in-the-loop for every uncertain case, workflow integration testing, and regulatory review. We cannot responsibly build that in a one-quarter project. The pivot to a training path was driven by this evidence, not by convenience.</a:t>
             </a:r>
           </a:p>
         </p:txBody>
@@ -885,22 +821,7 @@
           <a:lstStyle/>
           <a:p>
             <a:r>
-              <a:t>Building a CV tray checker without a training layer means no ground</a:t>
-            </a:r>
-          </a:p>
-          <a:p>
-            <a:r>
-              <a:t>    truth. You don't know the correct names, aliases, or lookalike pairs.</a:t>
-            </a:r>
-          </a:p>
-          <a:p>
-            <a:r>
-              <a:t>    The training loop builds and validates all of that at low cost. Once you</a:t>
-            </a:r>
-          </a:p>
-          <a:p>
-            <a:r>
-              <a:t>    have a validated module, that same data feeds any future CV system.</a:t>
+              <a:t>Here's the key insight. Building a CV tray checker without this training layer means you don't have ground truth. You don't know the correct instrument names, the correct aliases, the lookalike pairs, the tray-specific counts. The training loop builds and validates all of that at low cost, with printed cards and a laptop. Once you have a validated module — instructor-approved names, tested lookalike pairs, measured error categories — that same data feeds any future CV system. The training loop and CV are not competing approaches. The training loop creates the prerequisite infrastructure.</a:t>
             </a:r>
           </a:p>
         </p:txBody>
@@ -970,22 +891,7 @@
           <a:lstStyle/>
           <a:p>
             <a:r>
-              <a:t>This is the durable output. The fields mirror real count-sheet</a:t>
-            </a:r>
-          </a:p>
-          <a:p>
-            <a:r>
-              <a:t>    structure from Stryker's published sheets. The software prototype is</a:t>
-            </a:r>
-          </a:p>
-          <a:p>
-            <a:r>
-              <a:t>    throwaway -- future teams will choose their own stack -- but this schema</a:t>
-            </a:r>
-          </a:p>
-          <a:p>
-            <a:r>
-              <a:t>    captures the local tray knowledge that any solution needs.</a:t>
+              <a:t>This is the durable output. A file-backed tray module that defines what instruments belong in a tray, what they're called locally, what they're confused with, and how to assess them. The fields mirror real count-sheet structure — Stryker's published count sheets use tray name, reference number, description, location, quantity, check box. Our module adds learning-specific fields: aliases, lookalike pairs, study prompts, confidence tracking. The software prototype we built is throwaway — any future team will choose their own stack. But this schema captures the local tray knowledge that any solution needs. That's what survives.</a:t>
             </a:r>
           </a:p>
         </p:txBody>
@@ -1055,27 +961,7 @@
           <a:lstStyle/>
           <a:p>
             <a:r>
-              <a:t>Each instrument gets a printed card. The front has an AprilTag with no</a:t>
-            </a:r>
-          </a:p>
-          <a:p>
-            <a:r>
-              <a:t>    text, so during a test the learner can't read the answer off the card. The</a:t>
-            </a:r>
-          </a:p>
-          <a:p>
-            <a:r>
-              <a:t>    back has name, aliases, and features for study mode. The learner places</a:t>
-            </a:r>
-          </a:p>
-          <a:p>
-            <a:r>
-              <a:t>    cards on a table, the camera detects them, and the scoring engine compares</a:t>
-            </a:r>
-          </a:p>
-          <a:p>
-            <a:r>
-              <a:t>    against the tray template.</a:t>
+              <a:t>Each instrument gets a printed card. The front has an AprilTag marker — no text, so during a test the learner can't read the answer off the card. The back has the name, aliases, and features for study mode. The tag ID maps to an instrument ID through the module. The learner places cards on a table, the camera detects which tags are there, and the scoring engine compares their selection against the tray template.</a:t>
             </a:r>
           </a:p>
         </p:txBody>
@@ -1145,22 +1031,7 @@
           <a:lstStyle/>
           <a:p>
             <a:r>
-              <a:t>These six categories map directly to the literature. Zhu's 44\% wrong</a:t>
-            </a:r>
-          </a:p>
-          <a:p>
-            <a:r>
-              <a:t>    specification -- that's misidentified. Alfred's missing, wrong, extra,</a:t>
-            </a:r>
-          </a:p>
-          <a:p>
-            <a:r>
-              <a:t>    damaged -- we capture all of them. When a learner improves, we can say</a:t>
-            </a:r>
-          </a:p>
-          <a:p>
-            <a:r>
-              <a:t>    which type of error they reduced.</a:t>
+              <a:t>The scoring engine classifies every selection into six categories. These map directly to the error categories in the literature. Zhu's packaging study found 44\% were wrong specification — that's our misidentified category. Alfred found missing, wrong, extra, and damaged — we have all of those. Nichol found that lookalike substitution is a distinct error pattern — our misidentified category captures that separately from generic "wrong." When a learner improves from pre-test to post-test, we can say which type of error they reduced. That's more informative than a single accuracy number.</a:t>
             </a:r>
           </a:p>
         </p:txBody>
@@ -1230,22 +1101,7 @@
           <a:lstStyle/>
           <a:p>
             <a:r>
-              <a:t>After each tray sort, the learner rates confidence. This separates</a:t>
-            </a:r>
-          </a:p>
-          <a:p>
-            <a:r>
-              <a:t>    two failure modes: high-confidence errors (overconfidence, hardest to</a:t>
-            </a:r>
-          </a:p>
-          <a:p>
-            <a:r>
-              <a:t>    correct) and low-confidence correct answers (fragile knowledge). Both</a:t>
-            </a:r>
-          </a:p>
-          <a:p>
-            <a:r>
-              <a:t>    are visible in the export.</a:t>
+              <a:t>After each tray sort, the learner rates their confidence. This separates two very different failure modes. A high-confidence error means someone is confidently wrong — that's the hardest type to correct because the learner doesn't know they need help. Low-confidence correct means fragile knowledge that might not survive a week without review. Both are visible in the export.</a:t>
             </a:r>
           </a:p>
         </p:txBody>
@@ -1315,22 +1171,7 @@
           <a:lstStyle/>
           <a:p>
             <a:r>
-              <a:t>Each step has an evidence-based role. Pre/post use parallel variants</a:t>
-            </a:r>
-          </a:p>
-          <a:p>
-            <a:r>
-              <a:t>    so learners can't memorize exact layouts. Study cards are prompt-before-</a:t>
-            </a:r>
-          </a:p>
-          <a:p>
-            <a:r>
-              <a:t>    reveal -- retrieval practice, not passive review. Practice sort gives</a:t>
-            </a:r>
-          </a:p>
-          <a:p>
-            <a:r>
-              <a:t>    immediate error feedback. The full loop takes 45-60 minutes.</a:t>
+              <a:t>This is the full learner loop. Each step has a specific evidence-based role. The pre-test and post-test use parallel variants — same instrument families, different specific items — so the learner can't memorize the exact layout. Study cards are prompt-before-reveal: the learner commits to an answer before seeing it, which is retrieval practice, not passive review. The practice sort gives immediate error-category feedback — "you missed the Kelly clamp," "you selected curved instead of straight Mayo." The whole loop takes about 45 to 60 minutes for a first module.</a:t>
             </a:r>
           </a:p>
         </p:txBody>
@@ -1400,22 +1241,7 @@
           <a:lstStyle/>
           <a:p>
             <a:r>
-              <a:t>That's the research question this design answers. Not "does TrayGuard</a:t>
-            </a:r>
-          </a:p>
-          <a:p>
-            <a:r>
-              <a:t>    reduce OR delays." Not "does it certify competence." It's: can a novice</a:t>
-            </a:r>
-          </a:p>
-          <a:p>
-            <a:r>
-              <a:t>    improve on a simulated tray task after retrieval-centered practice? That's</a:t>
-            </a:r>
-          </a:p>
-          <a:p>
-            <a:r>
-              <a:t>    a question we can answer.</a:t>
+              <a:t>That's the research question this design answers. It's not "does TrayGuard reduce OR delays." It's not "does TrayGuard certify competence." It's: can a novice improve on a simulated local tray task after retrieval-centered practice? That's a question we can answer.</a:t>
             </a:r>
           </a:p>
         </p:txBody>
@@ -1485,27 +1311,7 @@
           <a:lstStyle/>
           <a:p>
             <a:r>
-              <a:t>Three different methods --- tray defect analysis, direct OR observation,</a:t>
-            </a:r>
-          </a:p>
-          <a:p>
-            <a:r>
-              <a:t>    package inspection --- all find the same thing: instruments are missing,</a:t>
-            </a:r>
-          </a:p>
-          <a:p>
-            <a:r>
-              <a:t>    wrong, damaged, or swapped at rates that affect every shift, every hospital.</a:t>
-            </a:r>
-          </a:p>
-          <a:p>
-            <a:r>
-              <a:t>    When delays happen, they average 10 minutes per affected case. That doesn't</a:t>
-            </a:r>
-          </a:p>
-          <a:p>
-            <a:r>
-              <a:t>    sound huge until you multiply by thousands of cases a year.</a:t>
+              <a:t>Three different methods — tray defect analysis, direct OR observation, package inspection — all find the same thing: instruments are missing, wrong, damaged, or swapped at rates that affect every shift, every hospital. When delays happen, they average 10 minutes per affected case. That doesn't sound huge until you multiply by thousands of cases a year. The largest error category in Zhu's study is "wrong specification" — same instrument family, wrong size or variant. The total count was correct; the specific instrument was wrong. That's a visual discrimination problem, not a counting problem.</a:t>
             </a:r>
           </a:p>
         </p:txBody>
@@ -1575,22 +1381,7 @@
           <a:lstStyle/>
           <a:p>
             <a:r>
-              <a:t>Each step validates a different piece of the evidence chain. Step 1</a:t>
-            </a:r>
-          </a:p>
-          <a:p>
-            <a:r>
-              <a:t>    ensures the measurement tool works. Step 2 tests learning mechanism. Step 3</a:t>
-            </a:r>
-          </a:p>
-          <a:p>
-            <a:r>
-              <a:t>    checks retention at 7 days. Step 4 brings in an expert. Only after all four</a:t>
-            </a:r>
-          </a:p>
-          <a:p>
-            <a:r>
-              <a:t>    should someone invest in an SPD pilot.</a:t>
+              <a:t>We designed a five-step study ladder. Each step validates a different piece of the evidence chain, and each step depends on the one before it. Step 1 — marker reliability — makes sure the cards scan correctly so app errors don't look like learner errors. Step 2 — the novice study — tests whether the learning mechanism works at all. Step 3 checks whether gains persist after 7 days — because same-day improvement is not retention. Step 4 brings in an expert to review whether our names, counts, and lookalike pairs make sense. Only after all four should someone invest in Step 5 — an SPD pilot. The current evidence supports starting at Step 1 and 2.</a:t>
             </a:r>
           </a:p>
         </p:txBody>
@@ -1660,22 +1451,7 @@
           <a:lstStyle/>
           <a:p>
             <a:r>
-              <a:t>The novice study uses a within-subject pre/post design. 8-12</a:t>
-            </a:r>
-          </a:p>
-          <a:p>
-            <a:r>
-              <a:t>    participants with no SPD experience. Primary measures: pre/post accuracy,</a:t>
-            </a:r>
-          </a:p>
-          <a:p>
-            <a:r>
-              <a:t>    error categories, duration, confidence. Convergent photo-ID test</a:t>
-            </a:r>
-          </a:p>
-          <a:p>
-            <a:r>
-              <a:t>    correlates tray accuracy with photo identification (target r $\ge$ 0.50).</a:t>
+              <a:t>The novice study uses a within-subject pre/post design, 8--12 participants with no SPD experience. One 60-minute session per person. Primary measures are pre/post accuracy, error-category counts, duration, and confidence calibration. We also include a convergent photo-ID test — learners identify instruments from photos without the tray context. If tray-sort accuracy correlates with photo-ID accuracy at r $\ge$ 0.50, we have evidence that the tray scores reflect instrument knowledge, not task-specific familiarity.</a:t>
             </a:r>
           </a:p>
         </p:txBody>
@@ -1745,22 +1521,7 @@
           <a:lstStyle/>
           <a:p>
             <a:r>
-              <a:t>Same-day post-test can't be called retention. Bell et al. showed</a:t>
-            </a:r>
-          </a:p>
-          <a:p>
-            <a:r>
-              <a:t>    medical gains decay measurably within 7 days. We require three</a:t>
-            </a:r>
-          </a:p>
-          <a:p>
-            <a:r>
-              <a:t>    falsification criteria: retain half the gain, stay above baseline, and</a:t>
-            </a:r>
-          </a:p>
-          <a:p>
-            <a:r>
-              <a:t>    70\% return rate. If these fail, we report immediate learning only.</a:t>
+              <a:t>A same-day post-test can't be called retention. Bell et al. showed medical-knowledge gains can decay measurably within 7 days. So we require a 7-day delayed check with explicit falsification criteria. The retention claim is supported only if three conditions are met: delayed accuracy retains at least half the immediate gain, it stays at least 5 percentage points above baseline, and at least 70\% of participants come back. If these fail, the project claim reverts to "immediate learning only." This is an honest go/no-go — we specify upfront what would falsify our claim.</a:t>
             </a:r>
           </a:p>
         </p:txBody>
@@ -1830,22 +1591,7 @@
           <a:lstStyle/>
           <a:p>
             <a:r>
-              <a:t>We don't work in an SPD. An instructor or SPD educator needs to</a:t>
-            </a:r>
-          </a:p>
-          <a:p>
-            <a:r>
-              <a:t>    review names, counts, distractors, and feedback. If they say the module</a:t>
-            </a:r>
-          </a:p>
-          <a:p>
-            <a:r>
-              <a:t>    is plausible, we proceed to an SPD pilot. If they find problems, we fix</a:t>
-            </a:r>
-          </a:p>
-          <a:p>
-            <a:r>
-              <a:t>    them first.</a:t>
+              <a:t>The main weakness of a student-built module is content validity. We don't work in an SPD. An instructor or SPD educator needs to review names, counts, distractors, lookalike pairs, and feedback language. If they say the module is plausible, we can proceed to an SPD pilot. If they find problems, we fix those before testing with real trainees.</a:t>
             </a:r>
           </a:p>
         </p:txBody>
@@ -1915,22 +1661,7 @@
           <a:lstStyle/>
           <a:p>
             <a:r>
-              <a:t>If the novice study shows learning, retention persists, and content</a:t>
-            </a:r>
-          </a:p>
-          <a:p>
-            <a:r>
-              <a:t>    is plausible, then investing in an SPD pilot is justified. If it fails,</a:t>
-            </a:r>
-          </a:p>
-          <a:p>
-            <a:r>
-              <a:t>    the problem may be harder than training alone can solve -- and that's</a:t>
-            </a:r>
-          </a:p>
-          <a:p>
-            <a:r>
-              <a:t>    useful evidence too.</a:t>
+              <a:t>This is the decision framework we leave the next team. If the novice study shows learning and the 7-day check shows retention, and an expert confirms the content is plausible, then investing in an SPD pilot is justified. If the novice study fails — if the measurement tool doesn't work, or novices don't improve — then the problem may be harder than training alone can solve, and that's a useful finding too.</a:t>
             </a:r>
           </a:p>
         </p:txBody>
@@ -2000,22 +1731,7 @@
           <a:lstStyle/>
           <a:p>
             <a:r>
-              <a:t>This sums up what we accomplished. We didn't build a deployable</a:t>
-            </a:r>
-          </a:p>
-          <a:p>
-            <a:r>
-              <a:t>    product. We built an evidence-backed argument for the right starting</a:t>
-            </a:r>
-          </a:p>
-          <a:p>
-            <a:r>
-              <a:t>    point, designed the measurement infrastructure, and left a testable</a:t>
-            </a:r>
-          </a:p>
-          <a:p>
-            <a:r>
-              <a:t>    protocol.</a:t>
+              <a:t>This sums up what we actually accomplished. We did not build a deployable product. We built an evidence-backed argument for what the right starting point is, designed the measurement and validation infrastructure, and left the next team with a testable protocol.</a:t>
             </a:r>
           </a:p>
         </p:txBody>
@@ -2085,37 +1801,19 @@
           <a:lstStyle/>
           <a:p>
             <a:r>
-              <a:t>We started thinking we'd build a camera that catches tray errors. We</a:t>
-            </a:r>
-          </a:p>
-          <a:p>
-            <a:r>
-              <a:t>    ended up understanding that tray errors are a system problem rooted in how</a:t>
-            </a:r>
-          </a:p>
-          <a:p>
-            <a:r>
-              <a:t>    the SPD workforce is structured, funded, and connected to the OR. A camera</a:t>
-            </a:r>
-          </a:p>
-          <a:p>
-            <a:r>
-              <a:t>    can't fix that. Training alone can't fix wage stagnation or staffing gaps.</a:t>
-            </a:r>
-          </a:p>
-          <a:p>
-            <a:r>
-              <a:t>    But a training loop can create the infrastructure every future solution</a:t>
-            </a:r>
-          </a:p>
-          <a:p>
-            <a:r>
-              <a:t>    needs. Our honest recommendation: take the schema, protocol, and criteria.</a:t>
-            </a:r>
-          </a:p>
-          <a:p>
-            <a:r>
-              <a:t>    Run the study.</a:t>
+              <a:t>We started this project thinking we'd build a camera that catches tray errors. We ended up understanding that tray errors are a system problem — rooted in how the SPD workforce is structured, funded, and connected to the OR. A camera can't fix a broken feedback loop. Training alone can't fix wage stagnation or staffing shortages. But a training loop can create the local content infrastructure that every future solution needs, and it can produce the first piece of measurable evidence.</a:t>
+            </a:r>
+          </a:p>
+          <a:p/>
+          <a:p>
+            <a:r>
+              <a:t>Our honest recommendation: take the module schema, the study protocol, and the falsification criteria we designed. Run the novice study. If it works, the SPD pilot is the next question. If it doesn't, the problem is even harder than we thought — and that's useful to know too.</a:t>
+            </a:r>
+          </a:p>
+          <a:p/>
+          <a:p>
+            <a:r>
+              <a:t>Thank you. Questions.</a:t>
             </a:r>
           </a:p>
         </p:txBody>
@@ -2185,22 +1883,7 @@
           <a:lstStyle/>
           <a:p>
             <a:r>
-              <a:t>This is what tray reconstruction looks like. A technician gets a bin</a:t>
-            </a:r>
-          </a:p>
-          <a:p>
-            <a:r>
-              <a:t>    of returned instruments mixed together from the last surgery and has to</a:t>
-            </a:r>
-          </a:p>
-          <a:p>
-            <a:r>
-              <a:t>    identify each one, check for damage, match to a count sheet that may use</a:t>
-            </a:r>
-          </a:p>
-          <a:p>
-            <a:r>
-              <a:t>    local names, and place it correctly. No labels. Local names. Time pressure.</a:t>
+              <a:t>This is what tray reconstruction looks like. A technician gets a bin of returned instruments — mixed together from the last surgery — and has to identify each one, check for damage, match it to a count sheet that may use local names or outdated photos, and place it in the right tray spot. There are no labels on the instruments. The count sheet might call something "Kelly clamp" when the actual instrument says "Crile" on the original package. And you're doing this under time pressure because the next case is waiting. This is a task that demands detailed visual memory, local knowledge, and sustained attention.</a:t>
             </a:r>
           </a:p>
         </p:txBody>
@@ -2270,32 +1953,13 @@
           <a:lstStyle/>
           <a:p>
             <a:r>
-              <a:t>We built a fishbone RCA across six categories: Product, Knowledge,</a:t>
-            </a:r>
-          </a:p>
-          <a:p>
-            <a:r>
-              <a:t>    Process, Information, Environment, Policy/Feedback. Underneath all six,</a:t>
-            </a:r>
-          </a:p>
-          <a:p>
-            <a:r>
-              <a:t>    three structural drivers explain why these problems persist. SPD evolved</a:t>
-            </a:r>
-          </a:p>
-          <a:p>
-            <a:r>
-              <a:t>    from materials management, not patient care, so there's no licensure.</a:t>
-            </a:r>
-          </a:p>
-          <a:p>
-            <a:r>
-              <a:t>    Hospital accounting treats SPD as a cost center -- error costs are</a:t>
-            </a:r>
-          </a:p>
-          <a:p>
-            <a:r>
-              <a:t>    invisible. And there's no information system to close the feedback loop.</a:t>
+              <a:t>We built a fishbone RCA across six categories. The quick version: the instrument itself is hard to identify because similar models differ only in subtle dimensions and markings wear off. The technician needs knowledge — but certification tests once, not repeatedly, and local names vary by hospital. The process has no double-check built in; you pick and check in one step. The count sheet might be outdated or use names nobody agrees on. The environment — production pressure, interruptions — makes detail work harder. And when an error does happen, the feedback loop to correct it is slow and manual.</a:t>
+            </a:r>
+          </a:p>
+          <a:p/>
+          <a:p>
+            <a:r>
+              <a:t>Underneath all six, three structural drivers explain why these problems persist year after year. Sterile processing evolved from materials management — think hospital supply closet — not from patient care. So there's no individual licensure, no board with enforcement authority, no recurring competency requirement. Hospital accounting treats SPD as a cost center: spending on staff or training shows up as expense, but the cost of errors is invisible. And there's no information system that connects a tray error discovered in the OR back to the specific tray, shift, and training gap that caused it. So the same errors repeat.</a:t>
             </a:r>
           </a:p>
         </p:txBody>
@@ -2365,27 +2029,7 @@
           <a:lstStyle/>
           <a:p>
             <a:r>
-              <a:t>This is the feedback loop that doesn't close. An instrument is missing</a:t>
-            </a:r>
-          </a:p>
-          <a:p>
-            <a:r>
-              <a:t>    during surgery. The scrub nurse fills an incident report on paper after the</a:t>
-            </a:r>
-          </a:p>
-          <a:p>
-            <a:r>
-              <a:t>    case. It reaches SPD management weeks later. By then nobody can connect it</a:t>
-            </a:r>
-          </a:p>
-          <a:p>
-            <a:r>
-              <a:t>    to the specific tray, shift, or training gap. So nothing changes. Even a</a:t>
-            </a:r>
-          </a:p>
-          <a:p>
-            <a:r>
-              <a:t>    perfect detector wouldn't fix this gap.</a:t>
+              <a:t>This is the feedback loop that doesn't close. An instrument is missing during surgery. The scrub nurse fills out an incident report — on paper, after the case. That report filters through risk management and reaches SPD management weeks later. By then, nobody can say which tray, which shift, which technician, or which training gap caused it. So nothing changes. The same error repeats next week. Even a perfect detector — one that caught every error at the assembly station — wouldn't fix this broken feedback architecture. It would tell you something was wrong but not why, or who needs help, or whether the count sheet itself is wrong.</a:t>
             </a:r>
           </a:p>
         </p:txBody>
@@ -2455,32 +2099,7 @@
           <a:lstStyle/>
           <a:p>
             <a:r>
-              <a:t>We mapped every intervention category in the literature and industry.</a:t>
-            </a:r>
-          </a:p>
-          <a:p>
-            <a:r>
-              <a:t>    Every one requires something we don't have: SPD deployment, policy</a:t>
-            </a:r>
-          </a:p>
-          <a:p>
-            <a:r>
-              <a:t>    authority, instrument inventory, or multi-stakeholder buy-in. Training is</a:t>
-            </a:r>
-          </a:p>
-          <a:p>
-            <a:r>
-              <a:t>    the only category buildable with printed cards and a laptop, validatable</a:t>
-            </a:r>
-          </a:p>
-          <a:p>
-            <a:r>
-              <a:t>    with a pre/post study, and creates durable infrastructure -- the local</a:t>
-            </a:r>
-          </a:p>
-          <a:p>
-            <a:r>
-              <a:t>    content module -- that future solutions need.</a:t>
+              <a:t>We mapped every intervention category we could find in the literature and industry. Automated tray checking, physical error-proofing like custom foam cutouts, workflow redesign with dual checks, decision-support kiosks at the workstation, tray rationalization, competency tracking systems — every one requires something we don't have. SPD deployment access, policy authority, instrument inventory, hospital utilization data, multi-stakeholder buy-in. Training is the only category that is buildable with printed cards and a laptop, that we can validate with a pre/post study, and that creates durable infrastructure — the local content module — that any future solution would need anyway.</a:t>
             </a:r>
           </a:p>
         </p:txBody>
@@ -2550,27 +2169,7 @@
           <a:lstStyle/>
           <a:p>
             <a:r>
-              <a:t>We need to be clear about what training does and doesn't do. It helps</a:t>
-            </a:r>
-          </a:p>
-          <a:p>
-            <a:r>
-              <a:t>    novices practice and produces measurable evidence. But it won't fix broken</a:t>
-            </a:r>
-          </a:p>
-          <a:p>
-            <a:r>
-              <a:t>    count sheets, solve staffing shortages, or close the feedback loop. Those</a:t>
-            </a:r>
-          </a:p>
-          <a:p>
-            <a:r>
-              <a:t>    are structural problems. Training is the one piece we can validate without</a:t>
-            </a:r>
-          </a:p>
-          <a:p>
-            <a:r>
-              <a:t>    a hospital partnership.</a:t>
+              <a:t>We need to be clear about what training does and doesn't do. A training tool can help a novice practice instrument names, lookalike distinctions, and count-sheet rules. It can produce pre/post evidence of improvement. That's real and measurable. But it won't fix an outdated count sheet. It won't solve staffing shortages, raise wages, or close the feedback loop from the OR. These are structural problems that require organizational and policy change. Training is not a substitute for those. It's the one piece we can build and validate without a hospital partnership. If it works, it gives the next team a reason to tackle the harder pieces. If it doesn't, that's useful evidence too.</a:t>
             </a:r>
           </a:p>
         </p:txBody>
@@ -2640,22 +2239,7 @@
           <a:lstStyle/>
           <a:p>
             <a:r>
-              <a:t>We built a complete YOLO training pipeline. On a clean dataset we got</a:t>
-            </a:r>
-          </a:p>
-          <a:p>
-            <a:r>
-              <a:t>    mAP50 of 0.990. The pipeline works. The problem is what happens when you</a:t>
-            </a:r>
-          </a:p>
-          <a:p>
-            <a:r>
-              <a:t>    test on conditions SPD workstations actually present. Every variation cost</a:t>
-            </a:r>
-          </a:p>
-          <a:p>
-            <a:r>
-              <a:t>    accuracy. The biggest drop -- overlay layout -- produced mAP50-95 of 0.389.</a:t>
+              <a:t>We built a complete YOLO training pipeline. On a clean published dataset — Lavado surgical instruments — we got mAP50 of 0.990. The pipeline works fine. The problem is what happens when you test on conditions that SPD workstations actually present. We ran seven staged experiments isolating brightness, background reflectivity, and layout occlusion. Every variation cost accuracy. The biggest drop — overlay layout, which simulates instruments touching in a tray — produced mAP50-95 of 0.389.</a:t>
             </a:r>
           </a:p>
         </p:txBody>
@@ -2725,22 +2309,7 @@
           <a:lstStyle/>
           <a:p>
             <a:r>
-              <a:t>This plot shows what happens as the light gap widens. Left: trained on</a:t>
-            </a:r>
-          </a:p>
-          <a:p>
-            <a:r>
-              <a:t>    darkest, tested on brighter. Right: trained on brightest, tested on dimmer.</a:t>
-            </a:r>
-          </a:p>
-          <a:p>
-            <a:r>
-              <a:t>    SPD lighting varies by workstation, time of day, fixture condition. Every</a:t>
-            </a:r>
-          </a:p>
-          <a:p>
-            <a:r>
-              <a:t>    variation costs detection reliability.</a:t>
+              <a:t>This plot shows what happens as the light gap widens. Left panel: trained on darkest, tested on brighter levels. Right panel: trained on brightest, tested on dimmer. The farther the gap, the worse the accuracy. SPD lighting varies by workstation, time of day, fixture condition. Every variation costs you detection reliability. This is not a solvable problem with more training data alone — you'd need to characterize and cover every lighting condition at every workstation.</a:t>
             </a:r>
           </a:p>
         </p:txBody>

</xml_diff>

<commit_message>
fdr presentation slides 1-20 complete
</commit_message>
<xml_diff>
--- a/final_paper/output/fdr_presentation.pptx
+++ b/final_paper/output/fdr_presentation.pptx
@@ -39,6 +39,11 @@
     <p:sldId id="287" r:id="rId39"/>
     <p:sldId id="288" r:id="rId40"/>
     <p:sldId id="289" r:id="rId41"/>
+    <p:sldId id="290" r:id="rId42"/>
+    <p:sldId id="291" r:id="rId43"/>
+    <p:sldId id="292" r:id="rId44"/>
+    <p:sldId id="293" r:id="rId45"/>
+    <p:sldId id="294" r:id="rId46"/>
   </p:sldIdLst>
   <p:sldSz cx="12191695" cy="6858000" type="screen4x3"/>
   <p:notesSz cx="6858000" cy="9144000"/>
@@ -605,7 +610,7 @@
           <a:lstStyle/>
           <a:p>
             <a:r>
-              <a:t>This is the most telling experiment. Left: separated layout — what you'd train on. Right: overlay — what a real tray looks like. Instruments in a tray touch and overlap. When we trained separated and tested on overlay, mAP50-95 dropped from 0.995 to 0.389. That means every time instruments overlap — which is most of the time in a real tray — the detector can't reliably tell what's there. You'd need to ask the technician to stop and rearrange before scanning, which defeats the purpose of an automated check.</a:t>
+              <a:t>This plot shows what happens as the light gap widens. Left panel: trained on darkest, tested on brighter levels. Right panel: trained on brightest, tested on dimmer. The farther the gap, the worse the accuracy. SPD lighting varies by workstation, time of day, fixture condition. Every variation costs you detection reliability. This is not a solvable problem with more training data alone — you'd need to characterize and cover every lighting condition at every workstation.</a:t>
             </a:r>
           </a:p>
         </p:txBody>
@@ -675,13 +680,7 @@
           <a:lstStyle/>
           <a:p>
             <a:r>
-              <a:t>This is the diagnostic result. We tested six real instrument classes — four scissors, a forcep, a scalpel. Per-class AP ranges from 0.000 to 0.862 depending on which split you look at. Different classes survive in different splits. The only class that transfers reliably is the scalpel — the most visually distinct instrument with a single blade versus multi-loop scissors.</a:t>
-            </a:r>
-          </a:p>
-          <a:p/>
-          <a:p>
-            <a:r>
-              <a:t>The pattern is caused by position-cue confounding. Each image has exactly one of each class at fixed positions per session. The model memorizes which class appears at which image location. When the position changes — which happens every time you process a different tray — the model fails. This isn't a problem you can fix with more data alone. You need randomized positions, which means a completely different data collection protocol.</a:t>
+              <a:t>Left: separated layout — what you'd train on. Right: overlay — what a real tray looks like. Instruments in a tray touch and overlap.</a:t>
             </a:r>
           </a:p>
         </p:txBody>
@@ -751,7 +750,7 @@
           <a:lstStyle/>
           <a:p>
             <a:r>
-              <a:t>The cumulative evidence is clear: CV detection works in matched, controlled conditions and degrades under every variation that SPD workflows present. A deployment-grade system would need site-specific data for every hospital, cross-manufacturer validation because Kienle showed big drops between brands, open-set rejection for unknown objects, human-in-the-loop for every uncertain case, workflow integration testing, and regulatory review. We cannot responsibly build that in a one-quarter project. The pivot to a training path was driven by this evidence, not by convenience.</a:t>
+              <a:t>When we trained separated and tested on overlay, mAP50-95 dropped from 0.995 to 0.389. That means every time instruments overlap — which is most of the time in a real tray — the detector can't reliably tell what's there. You'd need to ask the technician to stop and rearrange before scanning, which defeats the purpose of an automated check.</a:t>
             </a:r>
           </a:p>
         </p:txBody>
@@ -821,7 +820,13 @@
           <a:lstStyle/>
           <a:p>
             <a:r>
-              <a:t>Here's the key insight. Building a CV tray checker without this training layer means you don't have ground truth. You don't know the correct instrument names, the correct aliases, the lookalike pairs, the tray-specific counts. The training loop builds and validates all of that at low cost, with printed cards and a laptop. Once you have a validated module — instructor-approved names, tested lookalike pairs, measured error categories — that same data feeds any future CV system. The training loop and CV are not competing approaches. The training loop creates the prerequisite infrastructure.</a:t>
+              <a:t>This is the diagnostic result. We tested six real instrument classes — four scissors, a forcep, a scalpel. Per-class AP ranges from 0.000 to 0.862 depending on which split you look at. Different classes survive in different splits. The only class that transfers reliably is the scalpel — the most visually distinct instrument with a single blade versus multi-loop scissors.</a:t>
+            </a:r>
+          </a:p>
+          <a:p/>
+          <a:p>
+            <a:r>
+              <a:t>The pattern is caused by position-cue confounding. Each image has exactly one of each class at fixed positions per session. The model memorizes which class appears at which image location. When the position changes — which happens every time you process a different tray — the model fails. This isn't a problem you can fix with more data alone. You need randomized positions, which means a completely different data collection protocol.</a:t>
             </a:r>
           </a:p>
         </p:txBody>
@@ -891,7 +896,7 @@
           <a:lstStyle/>
           <a:p>
             <a:r>
-              <a:t>This is the durable output. A file-backed tray module that defines what instruments belong in a tray, what they're called locally, what they're confused with, and how to assess them. The fields mirror real count-sheet structure — Stryker's published count sheets use tray name, reference number, description, location, quantity, check box. Our module adds learning-specific fields: aliases, lookalike pairs, study prompts, confidence tracking. The software prototype we built is throwaway — any future team will choose their own stack. But this schema captures the local tray knowledge that any solution needs. That's what survives.</a:t>
+              <a:t>The cumulative evidence is clear: CV detection works in matched, controlled conditions and degrades under every variation that SPD workflows present. A deployment-grade system would need site-specific data for every hospital, cross-manufacturer validation because Kienle showed big drops between brands, open-set rejection for unknown objects, human-in-the-loop for every uncertain case, workflow integration testing, and regulatory review. We cannot responsibly build that in a one-quarter project. The pivot to a training path was driven by this evidence, not by convenience.</a:t>
             </a:r>
           </a:p>
         </p:txBody>
@@ -961,7 +966,7 @@
           <a:lstStyle/>
           <a:p>
             <a:r>
-              <a:t>Each instrument gets a printed card. The front has an AprilTag marker — no text, so during a test the learner can't read the answer off the card. The back has the name, aliases, and features for study mode. The tag ID maps to an instrument ID through the module. The learner places cards on a table, the camera detects which tags are there, and the scoring engine compares their selection against the tray template.</a:t>
+              <a:t>We mapped every intervention category we could find in the literature and industry. Automated tray checking, physical error-proofing like custom foam cutouts, workflow redesign with dual checks, decision-support kiosks at the workstation, tray rationalization, competency tracking systems — every one requires something we don't have. SPD deployment access, policy authority, instrument inventory, hospital utilization data, multi-stakeholder buy-in. Training is the only category that is buildable with printed cards and a laptop, that we can validate with a pre/post study, and that creates durable infrastructure — the local content module — that any future solution would need anyway.</a:t>
             </a:r>
           </a:p>
         </p:txBody>
@@ -1031,7 +1036,7 @@
           <a:lstStyle/>
           <a:p>
             <a:r>
-              <a:t>The scoring engine classifies every selection into six categories. These map directly to the error categories in the literature. Zhu's packaging study found 44\% were wrong specification — that's our misidentified category. Alfred found missing, wrong, extra, and damaged — we have all of those. Nichol found that lookalike substitution is a distinct error pattern — our misidentified category captures that separately from generic "wrong." When a learner improves from pre-test to post-test, we can say which type of error they reduced. That's more informative than a single accuracy number.</a:t>
+              <a:t>We need to be clear about what training does and doesn't do. A training tool can help a novice practice instrument names, lookalike distinctions, and count-sheet rules. It can produce pre/post evidence of improvement. That's real and measurable. But it won't fix an outdated count sheet. It won't solve staffing shortages, raise wages, or close the feedback loop from the OR. These are structural problems that require organizational and policy change. Training is not a substitute for those. It's the one piece we can build and validate without a hospital partnership. If it works, it gives the next team a reason to tackle the harder pieces. If it doesn't, that's useful evidence too.</a:t>
             </a:r>
           </a:p>
         </p:txBody>
@@ -1101,7 +1106,7 @@
           <a:lstStyle/>
           <a:p>
             <a:r>
-              <a:t>After each tray sort, the learner rates their confidence. This separates two very different failure modes. A high-confidence error means someone is confidently wrong — that's the hardest type to correct because the learner doesn't know they need help. Low-confidence correct means fragile knowledge that might not survive a week without review. Both are visible in the export.</a:t>
+              <a:t>Here's the key insight. Building a CV tray checker without this training layer means you don't have ground truth. You don't know the correct instrument names, the correct aliases, the lookalike pairs, the tray-specific counts. The training loop builds and validates all of that at low cost, with printed cards and a laptop. Once you have a validated module — instructor-approved names, tested lookalike pairs, measured error categories — that same data feeds any future CV system. The training loop and CV are not competing approaches. The training loop creates the prerequisite infrastructure.</a:t>
             </a:r>
           </a:p>
         </p:txBody>
@@ -1171,7 +1176,7 @@
           <a:lstStyle/>
           <a:p>
             <a:r>
-              <a:t>This is the full learner loop. Each step has a specific evidence-based role. The pre-test and post-test use parallel variants — same instrument families, different specific items — so the learner can't memorize the exact layout. Study cards are prompt-before-reveal: the learner commits to an answer before seeing it, which is retrieval practice, not passive review. The practice sort gives immediate error-category feedback — "you missed the Kelly clamp," "you selected curved instead of straight Mayo." The whole loop takes about 45 to 60 minutes for a first module.</a:t>
+              <a:t>This is the durable output. A file-backed tray module that defines what instruments belong in a tray, what they're called locally, what they're confused with, and how to assess them. The fields mirror real count-sheet structure — Stryker's published count sheets use tray name, reference number, description, location, quantity, check box. Our module adds learning-specific fields: aliases, lookalike pairs, study prompts, confidence tracking. The software prototype we built is throwaway — any future team will choose their own stack. But this schema captures the local tray knowledge that any solution needs. That's what survives.</a:t>
             </a:r>
           </a:p>
         </p:txBody>
@@ -1241,7 +1246,7 @@
           <a:lstStyle/>
           <a:p>
             <a:r>
-              <a:t>That's the research question this design answers. It's not "does TrayGuard reduce OR delays." It's not "does TrayGuard certify competence." It's: can a novice improve on a simulated local tray task after retrieval-centered practice? That's a question we can answer.</a:t>
+              <a:t>Each instrument gets a printed card. The front has an AprilTag marker — no text, so during a test the learner can't read the answer off the card. The back has the name, aliases, and features for study mode. The tag ID maps to an instrument ID through the module. The learner places cards on a table, the camera detects which tags are there, and the scoring engine compares their selection against the tray template.</a:t>
             </a:r>
           </a:p>
         </p:txBody>
@@ -1381,7 +1386,7 @@
           <a:lstStyle/>
           <a:p>
             <a:r>
-              <a:t>We designed a five-step study ladder. Each step validates a different piece of the evidence chain, and each step depends on the one before it. Step 1 — marker reliability — makes sure the cards scan correctly so app errors don't look like learner errors. Step 2 — the novice study — tests whether the learning mechanism works at all. Step 3 checks whether gains persist after 7 days — because same-day improvement is not retention. Step 4 brings in an expert to review whether our names, counts, and lookalike pairs make sense. Only after all four should someone invest in Step 5 — an SPD pilot. The current evidence supports starting at Step 1 and 2.</a:t>
+              <a:t>The scoring engine classifies every selection into six categories. These map directly to the error categories in the literature. Zhu's packaging study found 44\% were wrong specification — that's our misidentified category. Alfred found missing, wrong, extra, and damaged — we have all of those. Nichol found that lookalike substitution is a distinct error pattern — our misidentified category captures that separately from generic "wrong." When a learner improves from pre-test to post-test, we can say which type of error they reduced. That's more informative than a single accuracy number.</a:t>
             </a:r>
           </a:p>
         </p:txBody>
@@ -1451,7 +1456,7 @@
           <a:lstStyle/>
           <a:p>
             <a:r>
-              <a:t>The novice study uses a within-subject pre/post design, 8--12 participants with no SPD experience. One 60-minute session per person. Primary measures are pre/post accuracy, error-category counts, duration, and confidence calibration. We also include a convergent photo-ID test — learners identify instruments from photos without the tray context. If tray-sort accuracy correlates with photo-ID accuracy at r $\ge$ 0.50, we have evidence that the tray scores reflect instrument knowledge, not task-specific familiarity.</a:t>
+              <a:t>After each tray sort, the learner rates their confidence. This separates two very different failure modes. A high-confidence error means someone is confidently wrong — that's the hardest type to correct because the learner doesn't know they need help. Low-confidence correct means fragile knowledge that might not survive a week without review. Both are visible in the export.</a:t>
             </a:r>
           </a:p>
         </p:txBody>
@@ -1521,7 +1526,7 @@
           <a:lstStyle/>
           <a:p>
             <a:r>
-              <a:t>A same-day post-test can't be called retention. Bell et al. showed medical-knowledge gains can decay measurably within 7 days. So we require a 7-day delayed check with explicit falsification criteria. The retention claim is supported only if three conditions are met: delayed accuracy retains at least half the immediate gain, it stays at least 5 percentage points above baseline, and at least 70\% of participants come back. If these fail, the project claim reverts to "immediate learning only." This is an honest go/no-go — we specify upfront what would falsify our claim.</a:t>
+              <a:t>This is the full learner loop. Each step has a specific evidence-based role. The pre-test and post-test use parallel variants — same instrument families, different specific items — so the learner can't memorize the exact layout — Arthur et al. found that pre/post evaluation is the standard training assessment design \cite{arthur-et-al-2003}. Study cards are prompt-before-reveal: the learner commits to an answer before seeing it, which is retrieval practice, not passive review — Karpicke \&amp; Blunt and Roediger \&amp; Karpicke found retrieval practice doubles long-term retention over re-study \cite{karpicke-and-blunt-2011,roediger-and-karpicke-2006}. The practice sort gives immediate error-category feedback — "you missed the Kelly clamp," "you selected curved instead of straight Mayo" — Hattie \&amp; Timperley found the most effective feedback is task-specific and immediate \cite{hattie-and-timperley-2007}. The whole loop takes about 45 to 60 minutes for a first module.</a:t>
             </a:r>
           </a:p>
         </p:txBody>
@@ -1591,7 +1596,7 @@
           <a:lstStyle/>
           <a:p>
             <a:r>
-              <a:t>The main weakness of a student-built module is content validity. We don't work in an SPD. An instructor or SPD educator needs to review names, counts, distractors, lookalike pairs, and feedback language. If they say the module is plausible, we can proceed to an SPD pilot. If they find problems, we fix those before testing with real trainees.</a:t>
+              <a:t>That's the research question this design answers. It's not "does TrayGuard reduce OR delays." It's not "does TrayGuard certify competence." It's: can a novice improve on a simulated local tray task after retrieval-centered practice? That's a question we can answer.</a:t>
             </a:r>
           </a:p>
         </p:txBody>
@@ -1661,7 +1666,7 @@
           <a:lstStyle/>
           <a:p>
             <a:r>
-              <a:t>This is the decision framework we leave the next team. If the novice study shows learning and the 7-day check shows retention, and an expert confirms the content is plausible, then investing in an SPD pilot is justified. If the novice study fails — if the measurement tool doesn't work, or novices don't improve — then the problem may be harder than training alone can solve, and that's a useful finding too.</a:t>
+              <a:t>We designed a five-step study ladder. Each step validates a different piece of the evidence chain, and each step depends on the one before it. Step 1 — marker reliability — makes sure the cards scan correctly so app errors don't look like learner errors. Step 2 — the novice study — tests whether the learning mechanism works at all. Step 3 checks whether gains persist after 7 days — because same-day improvement is not retention. Step 4 brings in an expert to review whether our names, counts, and lookalike pairs make sense. Only after all four should someone invest in Step 5 — an SPD pilot. The current evidence supports starting at Step 1 and 2.</a:t>
             </a:r>
           </a:p>
         </p:txBody>
@@ -1731,7 +1736,7 @@
           <a:lstStyle/>
           <a:p>
             <a:r>
-              <a:t>This sums up what we actually accomplished. We did not build a deployable product. We built an evidence-backed argument for what the right starting point is, designed the measurement and validation infrastructure, and left the next team with a testable protocol.</a:t>
+              <a:t>The novice study uses a within-subject pre/post design, 8--12 participants with no SPD experience. One 60-minute session per person. Primary measures are pre/post accuracy, error-category counts, duration, and confidence calibration. We also include a convergent photo-ID test — learners identify instruments from photos without the tray context. If tray-sort accuracy correlates with photo-ID accuracy at r $\ge$ 0.50, we have evidence that the tray scores reflect instrument knowledge, not task-specific familiarity.</a:t>
             </a:r>
           </a:p>
         </p:txBody>
@@ -1801,19 +1806,7 @@
           <a:lstStyle/>
           <a:p>
             <a:r>
-              <a:t>We started this project thinking we'd build a camera that catches tray errors. We ended up understanding that tray errors are a system problem — rooted in how the SPD workforce is structured, funded, and connected to the OR. A camera can't fix a broken feedback loop. Training alone can't fix wage stagnation or staffing shortages. But a training loop can create the local content infrastructure that every future solution needs, and it can produce the first piece of measurable evidence.</a:t>
-            </a:r>
-          </a:p>
-          <a:p/>
-          <a:p>
-            <a:r>
-              <a:t>Our honest recommendation: take the module schema, the study protocol, and the falsification criteria we designed. Run the novice study. If it works, the SPD pilot is the next question. If it doesn't, the problem is even harder than we thought — and that's useful to know too.</a:t>
-            </a:r>
-          </a:p>
-          <a:p/>
-          <a:p>
-            <a:r>
-              <a:t>Thank you. Questions.</a:t>
+              <a:t>A same-day post-test can't be called retention. Bell et al. found knowledge decay was detectable within 7 days in a physician online tutorial \cite{bell-et-al-2008}. So we require a 7-day delayed check with explicit falsification criteria. The retention claim is supported only if three conditions are met: delayed accuracy retains at least half the immediate gain, it stays at least 5 percentage points above baseline, and at least 70\% of participants come back. If these fail, the project claim reverts to "immediate learning only." This is an honest go/no-go — we specify upfront what would falsify our claim.</a:t>
             </a:r>
           </a:p>
         </p:txBody>
@@ -1838,7 +1831,7 @@
 </p:notes>
 </file>
 
-<file path=ppt/notesSlides/notesSlide3.xml><?xml version="1.0" encoding="utf-8"?>
+<file path=ppt/notesSlides/notesSlide27.xml><?xml version="1.0" encoding="utf-8"?>
 <p:notes xmlns:a="http://schemas.openxmlformats.org/drawingml/2006/main" xmlns:p="http://schemas.openxmlformats.org/presentationml/2006/main" xmlns:r="http://schemas.openxmlformats.org/officeDocument/2006/relationships">
   <p:cSld>
     <p:spTree>
@@ -1883,7 +1876,7 @@
           <a:lstStyle/>
           <a:p>
             <a:r>
-              <a:t>This is what tray reconstruction looks like. A technician gets a bin of returned instruments — mixed together from the last surgery — and has to identify each one, check for damage, match it to a count sheet that may use local names or outdated photos, and place it in the right tray spot. There are no labels on the instruments. The count sheet might call something "Kelly clamp" when the actual instrument says "Crile" on the original package. And you're doing this under time pressure because the next case is waiting. This is a task that demands detailed visual memory, local knowledge, and sustained attention.</a:t>
+              <a:t>The main weakness of a student-built module is content validity. We don't work in an SPD. An instructor or SPD educator needs to review names, counts, distractors, lookalike pairs, and feedback language. If they say the module is plausible, we can proceed to an SPD pilot. If they find problems, we fix those before testing with real trainees.</a:t>
             </a:r>
           </a:p>
         </p:txBody>
@@ -1908,7 +1901,7 @@
 </p:notes>
 </file>
 
-<file path=ppt/notesSlides/notesSlide4.xml><?xml version="1.0" encoding="utf-8"?>
+<file path=ppt/notesSlides/notesSlide28.xml><?xml version="1.0" encoding="utf-8"?>
 <p:notes xmlns:a="http://schemas.openxmlformats.org/drawingml/2006/main" xmlns:p="http://schemas.openxmlformats.org/presentationml/2006/main" xmlns:r="http://schemas.openxmlformats.org/officeDocument/2006/relationships">
   <p:cSld>
     <p:spTree>
@@ -1953,13 +1946,7 @@
           <a:lstStyle/>
           <a:p>
             <a:r>
-              <a:t>We built a fishbone RCA across six categories. The quick version: the instrument itself is hard to identify because similar models differ only in subtle dimensions and markings wear off. The technician needs knowledge — but certification tests once, not repeatedly, and local names vary by hospital. The process has no double-check built in; you pick and check in one step. The count sheet might be outdated or use names nobody agrees on. The environment — production pressure, interruptions — makes detail work harder. And when an error does happen, the feedback loop to correct it is slow and manual.</a:t>
-            </a:r>
-          </a:p>
-          <a:p/>
-          <a:p>
-            <a:r>
-              <a:t>Underneath all six, three structural drivers explain why these problems persist year after year. Sterile processing evolved from materials management — think hospital supply closet — not from patient care. So there's no individual licensure, no board with enforcement authority, no recurring competency requirement. Hospital accounting treats SPD as a cost center: spending on staff or training shows up as expense, but the cost of errors is invisible. And there's no information system that connects a tray error discovered in the OR back to the specific tray, shift, and training gap that caused it. So the same errors repeat.</a:t>
+              <a:t>This is the decision framework we leave the next team. If the novice study shows learning and the 7-day check shows retention, and an expert confirms the content is plausible, then investing in an SPD pilot is justified. If the novice study fails — if the measurement tool doesn't work, or novices don't improve — then the problem may be harder than training alone can solve, and that's a useful finding too.</a:t>
             </a:r>
           </a:p>
         </p:txBody>
@@ -1984,7 +1971,7 @@
 </p:notes>
 </file>
 
-<file path=ppt/notesSlides/notesSlide5.xml><?xml version="1.0" encoding="utf-8"?>
+<file path=ppt/notesSlides/notesSlide29.xml><?xml version="1.0" encoding="utf-8"?>
 <p:notes xmlns:a="http://schemas.openxmlformats.org/drawingml/2006/main" xmlns:p="http://schemas.openxmlformats.org/presentationml/2006/main" xmlns:r="http://schemas.openxmlformats.org/officeDocument/2006/relationships">
   <p:cSld>
     <p:spTree>
@@ -2029,7 +2016,7 @@
           <a:lstStyle/>
           <a:p>
             <a:r>
-              <a:t>This is the feedback loop that doesn't close. An instrument is missing during surgery. The scrub nurse fills out an incident report — on paper, after the case. That report filters through risk management and reaches SPD management weeks later. By then, nobody can say which tray, which shift, which technician, or which training gap caused it. So nothing changes. The same error repeats next week. Even a perfect detector — one that caught every error at the assembly station — wouldn't fix this broken feedback architecture. It would tell you something was wrong but not why, or who needs help, or whether the count sheet itself is wrong.</a:t>
+              <a:t>This sums up what we actually accomplished. We did not build a deployable product. We built an evidence-backed argument for what the right starting point is, designed the measurement and validation infrastructure, and left the next team with a testable protocol.</a:t>
             </a:r>
           </a:p>
         </p:txBody>
@@ -2054,7 +2041,7 @@
 </p:notes>
 </file>
 
-<file path=ppt/notesSlides/notesSlide6.xml><?xml version="1.0" encoding="utf-8"?>
+<file path=ppt/notesSlides/notesSlide3.xml><?xml version="1.0" encoding="utf-8"?>
 <p:notes xmlns:a="http://schemas.openxmlformats.org/drawingml/2006/main" xmlns:p="http://schemas.openxmlformats.org/presentationml/2006/main" xmlns:r="http://schemas.openxmlformats.org/officeDocument/2006/relationships">
   <p:cSld>
     <p:spTree>
@@ -2099,7 +2086,7 @@
           <a:lstStyle/>
           <a:p>
             <a:r>
-              <a:t>We mapped every intervention category we could find in the literature and industry. Automated tray checking, physical error-proofing like custom foam cutouts, workflow redesign with dual checks, decision-support kiosks at the workstation, tray rationalization, competency tracking systems — every one requires something we don't have. SPD deployment access, policy authority, instrument inventory, hospital utilization data, multi-stakeholder buy-in. Training is the only category that is buildable with printed cards and a laptop, that we can validate with a pre/post study, and that creates durable infrastructure — the local content module — that any future solution would need anyway.</a:t>
+              <a:t>This is the core of the lookalike problem. Kelly and Crile forceps are in the same family — both hemostatic clamps with transverse serrations. But they differ in where those serrations run: Crile serrations cover the entire jaw length; Kelly serrations only cover the distal half. You can't tell them apart at a glance. And within each type, sizes vary — 6 inch, 7 inch, 8 inch. In Zhu's study, the most common error category was "wrong specification": a package calling for four 14cm Kelly clamps and two 16cm Kelly clamps might end up with the counts swapped. Total number correct, specific instrument wrong. That's a visual discrimination failure that a camera can't reliably catch, and that training can directly address.</a:t>
             </a:r>
           </a:p>
         </p:txBody>
@@ -2124,7 +2111,7 @@
 </p:notes>
 </file>
 
-<file path=ppt/notesSlides/notesSlide7.xml><?xml version="1.0" encoding="utf-8"?>
+<file path=ppt/notesSlides/notesSlide30.xml><?xml version="1.0" encoding="utf-8"?>
 <p:notes xmlns:a="http://schemas.openxmlformats.org/drawingml/2006/main" xmlns:p="http://schemas.openxmlformats.org/presentationml/2006/main" xmlns:r="http://schemas.openxmlformats.org/officeDocument/2006/relationships">
   <p:cSld>
     <p:spTree>
@@ -2169,7 +2156,19 @@
           <a:lstStyle/>
           <a:p>
             <a:r>
-              <a:t>We need to be clear about what training does and doesn't do. A training tool can help a novice practice instrument names, lookalike distinctions, and count-sheet rules. It can produce pre/post evidence of improvement. That's real and measurable. But it won't fix an outdated count sheet. It won't solve staffing shortages, raise wages, or close the feedback loop from the OR. These are structural problems that require organizational and policy change. Training is not a substitute for those. It's the one piece we can build and validate without a hospital partnership. If it works, it gives the next team a reason to tackle the harder pieces. If it doesn't, that's useful evidence too.</a:t>
+              <a:t>We started this project thinking we'd build a camera that catches tray errors. We ended up understanding that tray errors are a system problem — rooted in how the SPD workforce is structured, funded, and connected to the OR. A camera can't fix a broken feedback loop. Training alone can't fix wage stagnation or staffing shortages. But a training loop can create the local content infrastructure that every future solution needs, and it can produce the first piece of measurable evidence.</a:t>
+            </a:r>
+          </a:p>
+          <a:p/>
+          <a:p>
+            <a:r>
+              <a:t>Our honest recommendation: take the module schema, the study protocol, and the falsification criteria we designed. Run the novice study. If it works, the SPD pilot is the next question. If it doesn't, the problem is even harder than we thought — and that's useful to know too.</a:t>
+            </a:r>
+          </a:p>
+          <a:p/>
+          <a:p>
+            <a:r>
+              <a:t>Thank you. Questions.</a:t>
             </a:r>
           </a:p>
         </p:txBody>
@@ -2194,7 +2193,7 @@
 </p:notes>
 </file>
 
-<file path=ppt/notesSlides/notesSlide8.xml><?xml version="1.0" encoding="utf-8"?>
+<file path=ppt/notesSlides/notesSlide4.xml><?xml version="1.0" encoding="utf-8"?>
 <p:notes xmlns:a="http://schemas.openxmlformats.org/drawingml/2006/main" xmlns:p="http://schemas.openxmlformats.org/presentationml/2006/main" xmlns:r="http://schemas.openxmlformats.org/officeDocument/2006/relationships">
   <p:cSld>
     <p:spTree>
@@ -2239,7 +2238,7 @@
           <a:lstStyle/>
           <a:p>
             <a:r>
-              <a:t>We built a complete YOLO training pipeline. On a clean published dataset — Lavado surgical instruments — we got mAP50 of 0.990. The pipeline works fine. The problem is what happens when you test on conditions that SPD workstations actually present. We ran seven staged experiments isolating brightness, background reflectivity, and layout occlusion. Every variation cost accuracy. The biggest drop — overlay layout, which simulates instruments touching in a tray — produced mAP50-95 of 0.389.</a:t>
+              <a:t>This is what tray reconstruction looks like. A technician gets a bin of returned instruments — mixed together from the last surgery — and has to identify each one, check for damage, match it to a count sheet that may use local names or outdated photos, and place it in the right tray spot. There are no labels on the instruments. The count sheet might call something "Kelly clamp" when the actual instrument says "Crile" on the original package. And you're doing this under time pressure because the next case is waiting. This is a task that demands detailed visual memory, local knowledge, and sustained attention.</a:t>
             </a:r>
           </a:p>
         </p:txBody>
@@ -2264,7 +2263,7 @@
 </p:notes>
 </file>
 
-<file path=ppt/notesSlides/notesSlide9.xml><?xml version="1.0" encoding="utf-8"?>
+<file path=ppt/notesSlides/notesSlide5.xml><?xml version="1.0" encoding="utf-8"?>
 <p:notes xmlns:a="http://schemas.openxmlformats.org/drawingml/2006/main" xmlns:p="http://schemas.openxmlformats.org/presentationml/2006/main" xmlns:r="http://schemas.openxmlformats.org/officeDocument/2006/relationships">
   <p:cSld>
     <p:spTree>
@@ -2309,7 +2308,287 @@
           <a:lstStyle/>
           <a:p>
             <a:r>
-              <a:t>This plot shows what happens as the light gap widens. Left panel: trained on darkest, tested on brighter levels. Right panel: trained on brightest, tested on dimmer. The farther the gap, the worse the accuracy. SPD lighting varies by workstation, time of day, fixture condition. Every variation costs you detection reliability. This is not a solvable problem with more training data alone — you'd need to characterize and cover every lighting condition at every workstation.</a:t>
+              <a:t>This figure shows a taxonomy of common surgical instruments grouped by category: clamps, forceps, scissors, retractors, needle holders, and other specialized instruments. Each category includes multiple sub-types that differ in jaw shape, serration pattern, length, and tip geometry — features that trained SPD technicians must discriminate by sight during tray reconstruction.</a:t>
+            </a:r>
+          </a:p>
+        </p:txBody>
+      </p:sp>
+      <p:sp>
+        <p:nvSpPr>
+          <p:cNvPr id="4" name="Slide Number Placeholder 3"/>
+          <p:cNvSpPr>
+            <a:spLocks noGrp="1"/>
+          </p:cNvSpPr>
+          <p:nvPr>
+            <p:ph type="sldNum" idx="5" sz="quarter"/>
+          </p:nvPr>
+        </p:nvSpPr>
+        <p:spPr/>
+      </p:sp>
+    </p:spTree>
+  </p:cSld>
+  <p:clrMapOvr>
+    <a:masterClrMapping/>
+  </p:clrMapOvr>
+</p:notes>
+</file>
+
+<file path=ppt/notesSlides/notesSlide6.xml><?xml version="1.0" encoding="utf-8"?>
+<p:notes xmlns:a="http://schemas.openxmlformats.org/drawingml/2006/main" xmlns:p="http://schemas.openxmlformats.org/presentationml/2006/main" xmlns:r="http://schemas.openxmlformats.org/officeDocument/2006/relationships">
+  <p:cSld>
+    <p:spTree>
+      <p:nvGrpSpPr>
+        <p:cNvPr id="1" name=""/>
+        <p:cNvGrpSpPr/>
+        <p:nvPr/>
+      </p:nvGrpSpPr>
+      <p:grpSpPr>
+        <a:xfrm>
+          <a:off x="0" y="0"/>
+          <a:ext cx="0" cy="0"/>
+          <a:chOff x="0" y="0"/>
+          <a:chExt cx="0" cy="0"/>
+        </a:xfrm>
+      </p:grpSpPr>
+      <p:sp>
+        <p:nvSpPr>
+          <p:cNvPr id="2" name="Slide Image Placeholder 1"/>
+          <p:cNvSpPr>
+            <a:spLocks noGrp="1"/>
+          </p:cNvSpPr>
+          <p:nvPr>
+            <p:ph type="sldImg" idx="2"/>
+          </p:nvPr>
+        </p:nvSpPr>
+        <p:spPr/>
+      </p:sp>
+      <p:sp>
+        <p:nvSpPr>
+          <p:cNvPr id="3" name="Notes Placeholder 2"/>
+          <p:cNvSpPr>
+            <a:spLocks noGrp="1"/>
+          </p:cNvSpPr>
+          <p:nvPr>
+            <p:ph type="body" idx="3" sz="quarter"/>
+          </p:nvPr>
+        </p:nvSpPr>
+        <p:spPr/>
+        <p:txBody>
+          <a:bodyPr/>
+          <a:lstStyle/>
+          <a:p>
+            <a:r>
+              <a:t>We built a fishbone RCA across six categories. The quick version: the instrument itself is hard to identify because similar models differ only in subtle dimensions and markings wear off. The technician needs knowledge — but certification tests once, not repeatedly, and local names vary by hospital. The process has no double-check built in; you pick and check in one step. The count sheet might be outdated or use names nobody agrees on. The environment — production pressure, interruptions — makes detail work harder. And when an error does happen, the feedback loop to correct it is slow and manual.</a:t>
+            </a:r>
+          </a:p>
+        </p:txBody>
+      </p:sp>
+      <p:sp>
+        <p:nvSpPr>
+          <p:cNvPr id="4" name="Slide Number Placeholder 3"/>
+          <p:cNvSpPr>
+            <a:spLocks noGrp="1"/>
+          </p:cNvSpPr>
+          <p:nvPr>
+            <p:ph type="sldNum" idx="5" sz="quarter"/>
+          </p:nvPr>
+        </p:nvSpPr>
+        <p:spPr/>
+      </p:sp>
+    </p:spTree>
+  </p:cSld>
+  <p:clrMapOvr>
+    <a:masterClrMapping/>
+  </p:clrMapOvr>
+</p:notes>
+</file>
+
+<file path=ppt/notesSlides/notesSlide7.xml><?xml version="1.0" encoding="utf-8"?>
+<p:notes xmlns:a="http://schemas.openxmlformats.org/drawingml/2006/main" xmlns:p="http://schemas.openxmlformats.org/presentationml/2006/main" xmlns:r="http://schemas.openxmlformats.org/officeDocument/2006/relationships">
+  <p:cSld>
+    <p:spTree>
+      <p:nvGrpSpPr>
+        <p:cNvPr id="1" name=""/>
+        <p:cNvGrpSpPr/>
+        <p:nvPr/>
+      </p:nvGrpSpPr>
+      <p:grpSpPr>
+        <a:xfrm>
+          <a:off x="0" y="0"/>
+          <a:ext cx="0" cy="0"/>
+          <a:chOff x="0" y="0"/>
+          <a:chExt cx="0" cy="0"/>
+        </a:xfrm>
+      </p:grpSpPr>
+      <p:sp>
+        <p:nvSpPr>
+          <p:cNvPr id="2" name="Slide Image Placeholder 1"/>
+          <p:cNvSpPr>
+            <a:spLocks noGrp="1"/>
+          </p:cNvSpPr>
+          <p:nvPr>
+            <p:ph type="sldImg" idx="2"/>
+          </p:nvPr>
+        </p:nvSpPr>
+        <p:spPr/>
+      </p:sp>
+      <p:sp>
+        <p:nvSpPr>
+          <p:cNvPr id="3" name="Notes Placeholder 2"/>
+          <p:cNvSpPr>
+            <a:spLocks noGrp="1"/>
+          </p:cNvSpPr>
+          <p:nvPr>
+            <p:ph type="body" idx="3" sz="quarter"/>
+          </p:nvPr>
+        </p:nvSpPr>
+        <p:spPr/>
+        <p:txBody>
+          <a:bodyPr/>
+          <a:lstStyle/>
+          <a:p>
+            <a:r>
+              <a:t>Underneath all six, three structural drivers explain why these problems persist year after year. Sterile processing evolved from materials management — think hospital supply closet — not from patient care. So there's no individual licensure, no board with enforcement authority, no recurring competency requirement. Hospital accounting treats SPD as a cost center: spending on staff or training shows up as expense, but the cost of errors is invisible. And there's no information system that connects a tray error discovered in the OR back to the specific tray, shift, and training gap that caused it. So the same errors repeat.</a:t>
+            </a:r>
+          </a:p>
+        </p:txBody>
+      </p:sp>
+      <p:sp>
+        <p:nvSpPr>
+          <p:cNvPr id="4" name="Slide Number Placeholder 3"/>
+          <p:cNvSpPr>
+            <a:spLocks noGrp="1"/>
+          </p:cNvSpPr>
+          <p:nvPr>
+            <p:ph type="sldNum" idx="5" sz="quarter"/>
+          </p:nvPr>
+        </p:nvSpPr>
+        <p:spPr/>
+      </p:sp>
+    </p:spTree>
+  </p:cSld>
+  <p:clrMapOvr>
+    <a:masterClrMapping/>
+  </p:clrMapOvr>
+</p:notes>
+</file>
+
+<file path=ppt/notesSlides/notesSlide8.xml><?xml version="1.0" encoding="utf-8"?>
+<p:notes xmlns:a="http://schemas.openxmlformats.org/drawingml/2006/main" xmlns:p="http://schemas.openxmlformats.org/presentationml/2006/main" xmlns:r="http://schemas.openxmlformats.org/officeDocument/2006/relationships">
+  <p:cSld>
+    <p:spTree>
+      <p:nvGrpSpPr>
+        <p:cNvPr id="1" name=""/>
+        <p:cNvGrpSpPr/>
+        <p:nvPr/>
+      </p:nvGrpSpPr>
+      <p:grpSpPr>
+        <a:xfrm>
+          <a:off x="0" y="0"/>
+          <a:ext cx="0" cy="0"/>
+          <a:chOff x="0" y="0"/>
+          <a:chExt cx="0" cy="0"/>
+        </a:xfrm>
+      </p:grpSpPr>
+      <p:sp>
+        <p:nvSpPr>
+          <p:cNvPr id="2" name="Slide Image Placeholder 1"/>
+          <p:cNvSpPr>
+            <a:spLocks noGrp="1"/>
+          </p:cNvSpPr>
+          <p:nvPr>
+            <p:ph type="sldImg" idx="2"/>
+          </p:nvPr>
+        </p:nvSpPr>
+        <p:spPr/>
+      </p:sp>
+      <p:sp>
+        <p:nvSpPr>
+          <p:cNvPr id="3" name="Notes Placeholder 2"/>
+          <p:cNvSpPr>
+            <a:spLocks noGrp="1"/>
+          </p:cNvSpPr>
+          <p:nvPr>
+            <p:ph type="body" idx="3" sz="quarter"/>
+          </p:nvPr>
+        </p:nvSpPr>
+        <p:spPr/>
+        <p:txBody>
+          <a:bodyPr/>
+          <a:lstStyle/>
+          <a:p>
+            <a:r>
+              <a:t>This is the feedback loop that doesn't close. An instrument is missing during surgery. The scrub nurse fills out an incident report — on paper, after the case. That report filters through risk management and reaches SPD management weeks later. By then, nobody can say which tray, which shift, which technician, or which training gap caused it. So nothing changes. The same error repeats next week. Even a perfect detector — one that caught every error at the assembly station — wouldn't fix this broken feedback architecture. It would tell you something was wrong but not why, or who needs help, or whether the count sheet itself is wrong.</a:t>
+            </a:r>
+          </a:p>
+        </p:txBody>
+      </p:sp>
+      <p:sp>
+        <p:nvSpPr>
+          <p:cNvPr id="4" name="Slide Number Placeholder 3"/>
+          <p:cNvSpPr>
+            <a:spLocks noGrp="1"/>
+          </p:cNvSpPr>
+          <p:nvPr>
+            <p:ph type="sldNum" idx="5" sz="quarter"/>
+          </p:nvPr>
+        </p:nvSpPr>
+        <p:spPr/>
+      </p:sp>
+    </p:spTree>
+  </p:cSld>
+  <p:clrMapOvr>
+    <a:masterClrMapping/>
+  </p:clrMapOvr>
+</p:notes>
+</file>
+
+<file path=ppt/notesSlides/notesSlide9.xml><?xml version="1.0" encoding="utf-8"?>
+<p:notes xmlns:a="http://schemas.openxmlformats.org/drawingml/2006/main" xmlns:p="http://schemas.openxmlformats.org/presentationml/2006/main" xmlns:r="http://schemas.openxmlformats.org/officeDocument/2006/relationships">
+  <p:cSld>
+    <p:spTree>
+      <p:nvGrpSpPr>
+        <p:cNvPr id="1" name=""/>
+        <p:cNvGrpSpPr/>
+        <p:nvPr/>
+      </p:nvGrpSpPr>
+      <p:grpSpPr>
+        <a:xfrm>
+          <a:off x="0" y="0"/>
+          <a:ext cx="0" cy="0"/>
+          <a:chOff x="0" y="0"/>
+          <a:chExt cx="0" cy="0"/>
+        </a:xfrm>
+      </p:grpSpPr>
+      <p:sp>
+        <p:nvSpPr>
+          <p:cNvPr id="2" name="Slide Image Placeholder 1"/>
+          <p:cNvSpPr>
+            <a:spLocks noGrp="1"/>
+          </p:cNvSpPr>
+          <p:nvPr>
+            <p:ph type="sldImg" idx="2"/>
+          </p:nvPr>
+        </p:nvSpPr>
+        <p:spPr/>
+      </p:sp>
+      <p:sp>
+        <p:nvSpPr>
+          <p:cNvPr id="3" name="Notes Placeholder 2"/>
+          <p:cNvSpPr>
+            <a:spLocks noGrp="1"/>
+          </p:cNvSpPr>
+          <p:nvPr>
+            <p:ph type="body" idx="3" sz="quarter"/>
+          </p:nvPr>
+        </p:nvSpPr>
+        <p:spPr/>
+        <p:txBody>
+          <a:bodyPr/>
+          <a:lstStyle/>
+          <a:p>
+            <a:r>
+              <a:t>We built a complete YOLO training pipeline. On a clean published dataset — Lavado surgical instruments — we got mAP50 of 0.990. The pipeline works fine. The problem is what happens when you test on conditions that SPD workstations actually present. We ran seven staged experiments isolating brightness, background reflectivity, and layout occlusion. Every variation cost accuracy. The biggest drop — overlay layout, which simulates instruments touching in a tray — produced mAP50-95 of 0.389.</a:t>
             </a:r>
           </a:p>
         </p:txBody>
@@ -6452,6 +6731,216 @@
       <p:pic>
         <p:nvPicPr>
           <p:cNvPr id="2" name="Picture 1" descr="slide-34.png"/>
+          <p:cNvPicPr>
+            <a:picLocks noChangeAspect="1"/>
+          </p:cNvPicPr>
+          <p:nvPr/>
+        </p:nvPicPr>
+        <p:blipFill>
+          <a:blip r:embed="rId2"/>
+          <a:stretch>
+            <a:fillRect/>
+          </a:stretch>
+        </p:blipFill>
+        <p:spPr>
+          <a:xfrm>
+            <a:off x="0" y="0"/>
+            <a:ext cx="12191695" cy="6858000"/>
+          </a:xfrm>
+          <a:prstGeom prst="rect">
+            <a:avLst/>
+          </a:prstGeom>
+        </p:spPr>
+      </p:pic>
+    </p:spTree>
+  </p:cSld>
+  <p:clrMapOvr>
+    <a:masterClrMapping/>
+  </p:clrMapOvr>
+</p:sld>
+</file>
+
+<file path=ppt/slides/slide35.xml><?xml version="1.0" encoding="utf-8"?>
+<p:sld xmlns:a="http://schemas.openxmlformats.org/drawingml/2006/main" xmlns:p="http://schemas.openxmlformats.org/presentationml/2006/main" xmlns:r="http://schemas.openxmlformats.org/officeDocument/2006/relationships">
+  <p:cSld>
+    <p:spTree>
+      <p:nvGrpSpPr>
+        <p:cNvPr id="1" name=""/>
+        <p:cNvGrpSpPr/>
+        <p:nvPr/>
+      </p:nvGrpSpPr>
+      <p:grpSpPr/>
+      <p:pic>
+        <p:nvPicPr>
+          <p:cNvPr id="2" name="Picture 1" descr="slide-35.png"/>
+          <p:cNvPicPr>
+            <a:picLocks noChangeAspect="1"/>
+          </p:cNvPicPr>
+          <p:nvPr/>
+        </p:nvPicPr>
+        <p:blipFill>
+          <a:blip r:embed="rId2"/>
+          <a:stretch>
+            <a:fillRect/>
+          </a:stretch>
+        </p:blipFill>
+        <p:spPr>
+          <a:xfrm>
+            <a:off x="0" y="0"/>
+            <a:ext cx="12191695" cy="6858000"/>
+          </a:xfrm>
+          <a:prstGeom prst="rect">
+            <a:avLst/>
+          </a:prstGeom>
+        </p:spPr>
+      </p:pic>
+    </p:spTree>
+  </p:cSld>
+  <p:clrMapOvr>
+    <a:masterClrMapping/>
+  </p:clrMapOvr>
+</p:sld>
+</file>
+
+<file path=ppt/slides/slide36.xml><?xml version="1.0" encoding="utf-8"?>
+<p:sld xmlns:a="http://schemas.openxmlformats.org/drawingml/2006/main" xmlns:p="http://schemas.openxmlformats.org/presentationml/2006/main" xmlns:r="http://schemas.openxmlformats.org/officeDocument/2006/relationships">
+  <p:cSld>
+    <p:spTree>
+      <p:nvGrpSpPr>
+        <p:cNvPr id="1" name=""/>
+        <p:cNvGrpSpPr/>
+        <p:nvPr/>
+      </p:nvGrpSpPr>
+      <p:grpSpPr/>
+      <p:pic>
+        <p:nvPicPr>
+          <p:cNvPr id="2" name="Picture 1" descr="slide-36.png"/>
+          <p:cNvPicPr>
+            <a:picLocks noChangeAspect="1"/>
+          </p:cNvPicPr>
+          <p:nvPr/>
+        </p:nvPicPr>
+        <p:blipFill>
+          <a:blip r:embed="rId2"/>
+          <a:stretch>
+            <a:fillRect/>
+          </a:stretch>
+        </p:blipFill>
+        <p:spPr>
+          <a:xfrm>
+            <a:off x="0" y="0"/>
+            <a:ext cx="12191695" cy="6858000"/>
+          </a:xfrm>
+          <a:prstGeom prst="rect">
+            <a:avLst/>
+          </a:prstGeom>
+        </p:spPr>
+      </p:pic>
+    </p:spTree>
+  </p:cSld>
+  <p:clrMapOvr>
+    <a:masterClrMapping/>
+  </p:clrMapOvr>
+</p:sld>
+</file>
+
+<file path=ppt/slides/slide37.xml><?xml version="1.0" encoding="utf-8"?>
+<p:sld xmlns:a="http://schemas.openxmlformats.org/drawingml/2006/main" xmlns:p="http://schemas.openxmlformats.org/presentationml/2006/main" xmlns:r="http://schemas.openxmlformats.org/officeDocument/2006/relationships">
+  <p:cSld>
+    <p:spTree>
+      <p:nvGrpSpPr>
+        <p:cNvPr id="1" name=""/>
+        <p:cNvGrpSpPr/>
+        <p:nvPr/>
+      </p:nvGrpSpPr>
+      <p:grpSpPr/>
+      <p:pic>
+        <p:nvPicPr>
+          <p:cNvPr id="2" name="Picture 1" descr="slide-37.png"/>
+          <p:cNvPicPr>
+            <a:picLocks noChangeAspect="1"/>
+          </p:cNvPicPr>
+          <p:nvPr/>
+        </p:nvPicPr>
+        <p:blipFill>
+          <a:blip r:embed="rId2"/>
+          <a:stretch>
+            <a:fillRect/>
+          </a:stretch>
+        </p:blipFill>
+        <p:spPr>
+          <a:xfrm>
+            <a:off x="0" y="0"/>
+            <a:ext cx="12191695" cy="6858000"/>
+          </a:xfrm>
+          <a:prstGeom prst="rect">
+            <a:avLst/>
+          </a:prstGeom>
+        </p:spPr>
+      </p:pic>
+    </p:spTree>
+  </p:cSld>
+  <p:clrMapOvr>
+    <a:masterClrMapping/>
+  </p:clrMapOvr>
+</p:sld>
+</file>
+
+<file path=ppt/slides/slide38.xml><?xml version="1.0" encoding="utf-8"?>
+<p:sld xmlns:a="http://schemas.openxmlformats.org/drawingml/2006/main" xmlns:p="http://schemas.openxmlformats.org/presentationml/2006/main" xmlns:r="http://schemas.openxmlformats.org/officeDocument/2006/relationships">
+  <p:cSld>
+    <p:spTree>
+      <p:nvGrpSpPr>
+        <p:cNvPr id="1" name=""/>
+        <p:cNvGrpSpPr/>
+        <p:nvPr/>
+      </p:nvGrpSpPr>
+      <p:grpSpPr/>
+      <p:pic>
+        <p:nvPicPr>
+          <p:cNvPr id="2" name="Picture 1" descr="slide-38.png"/>
+          <p:cNvPicPr>
+            <a:picLocks noChangeAspect="1"/>
+          </p:cNvPicPr>
+          <p:nvPr/>
+        </p:nvPicPr>
+        <p:blipFill>
+          <a:blip r:embed="rId2"/>
+          <a:stretch>
+            <a:fillRect/>
+          </a:stretch>
+        </p:blipFill>
+        <p:spPr>
+          <a:xfrm>
+            <a:off x="0" y="0"/>
+            <a:ext cx="12191695" cy="6858000"/>
+          </a:xfrm>
+          <a:prstGeom prst="rect">
+            <a:avLst/>
+          </a:prstGeom>
+        </p:spPr>
+      </p:pic>
+    </p:spTree>
+  </p:cSld>
+  <p:clrMapOvr>
+    <a:masterClrMapping/>
+  </p:clrMapOvr>
+</p:sld>
+</file>
+
+<file path=ppt/slides/slide39.xml><?xml version="1.0" encoding="utf-8"?>
+<p:sld xmlns:a="http://schemas.openxmlformats.org/drawingml/2006/main" xmlns:p="http://schemas.openxmlformats.org/presentationml/2006/main" xmlns:r="http://schemas.openxmlformats.org/officeDocument/2006/relationships">
+  <p:cSld>
+    <p:spTree>
+      <p:nvGrpSpPr>
+        <p:cNvPr id="1" name=""/>
+        <p:cNvGrpSpPr/>
+        <p:nvPr/>
+      </p:nvGrpSpPr>
+      <p:grpSpPr/>
+      <p:pic>
+        <p:nvPicPr>
+          <p:cNvPr id="2" name="Picture 1" descr="slide-39.png"/>
           <p:cNvPicPr>
             <a:picLocks noChangeAspect="1"/>
           </p:cNvPicPr>

</xml_diff>